<commit_message>
Replace Problem-slide stats with primary-sourced figures
The 80% / 10-15% figures traced only to marketing blogs. Replaced with
peer-reviewed and industry-standard primary sources:

- 80% -> 86% diet-app abandonment (JMIR 2024 scoping review, e56897)
- 10-15% -> ~3% day-30 retention (AppsFlyer 2024 benchmarks, corroborated
  by Statista)

Updated across .html, .pptx, build_deck.py, and rewrote sources doc with
exact citations and notes explaining the correction.

https://claude.ai/code/session_01PqTSVq8AzjnMfQ5oMPJVDk
</commit_message>
<xml_diff>
--- a/docs/luli-fitness-presentation.pptx
+++ b/docs/luli-fitness-presentation.pptx
@@ -8914,7 +8914,7 @@
                 </a:solidFill>
                 <a:latin typeface="Arial"/>
               </a:rPr>
-              <a:t>80%</a:t>
+              <a:t>86%</a:t>
             </a:r>
           </a:p>
         </p:txBody>
@@ -8959,8 +8959,8 @@
                 </a:solidFill>
                 <a:latin typeface="Arial"/>
               </a:rPr>
-              <a:t>of users abandon nutrition
-apps within 2 weeks</a:t>
+              <a:t>of users abandon diet &amp;
+nutrition apps</a:t>
             </a:r>
           </a:p>
         </p:txBody>
@@ -9005,7 +9005,7 @@
                 </a:solidFill>
                 <a:latin typeface="Arial"/>
               </a:rPr>
-              <a:t>10-15%</a:t>
+              <a:t>~3%</a:t>
             </a:r>
           </a:p>
         </p:txBody>
@@ -9050,8 +9050,8 @@
                 </a:solidFill>
                 <a:latin typeface="Arial"/>
               </a:rPr>
-              <a:t>average retention for health
-apps after 30 days</a:t>
+              <a:t>health &amp; fitness app
+retention at day 30</a:t>
             </a:r>
           </a:p>
         </p:txBody>

</xml_diff>